<commit_message>
FINAL Round-1 dataset: 212 approved rows (replay-generated), review receipts, signed extraction reference set
</commit_message>
<xml_diff>
--- a/ClauseChain_Pitch_Deck.pptx
+++ b/ClauseChain_Pitch_Deck.pptx
@@ -11976,7 +11976,7 @@
                 <a:ea typeface="Calibri" pitchFamily="34" charset="-122"/>
                 <a:cs typeface="Calibri" pitchFamily="34" charset="-120"/>
               </a:rPr>
-              <a:t>THE CHAMPIONSHIP CASE</a:t>
+              <a:t>OUR CASE</a:t>
             </a:r>
             <a:endParaRPr lang="en-US" sz="1300" dirty="0"/>
           </a:p>
@@ -12015,7 +12015,29 @@
                 <a:ea typeface="Titillium Web" pitchFamily="34" charset="-122"/>
                 <a:cs typeface="Titillium Web" pitchFamily="34" charset="-120"/>
               </a:rPr>
-              <a:t>Why ClauseChain should win</a:t>
+              <a:t>Why </a:t>
+            </a:r>
+            <a:r>
+              <a:rPr lang="en-US" sz="3400" b="1" dirty="0" err="1">
+                <a:solidFill>
+                  <a:srgbClr val="FFFFFF"/>
+                </a:solidFill>
+                <a:latin typeface="Titillium Web" pitchFamily="34" charset="0"/>
+                <a:ea typeface="Titillium Web" pitchFamily="34" charset="-122"/>
+                <a:cs typeface="Titillium Web" pitchFamily="34" charset="-120"/>
+              </a:rPr>
+              <a:t>ClauseChain</a:t>
+            </a:r>
+            <a:r>
+              <a:rPr lang="en-US" sz="3400" b="1" dirty="0">
+                <a:solidFill>
+                  <a:srgbClr val="FFFFFF"/>
+                </a:solidFill>
+                <a:latin typeface="Titillium Web" pitchFamily="34" charset="0"/>
+                <a:ea typeface="Titillium Web" pitchFamily="34" charset="-122"/>
+                <a:cs typeface="Titillium Web" pitchFamily="34" charset="-120"/>
+              </a:rPr>
+              <a:t> can be a Good Solution</a:t>
             </a:r>
             <a:endParaRPr lang="en-US" sz="3400" dirty="0"/>
           </a:p>
@@ -12076,7 +12098,7 @@
                 <a:ea typeface="Calibri" pitchFamily="34" charset="-122"/>
                 <a:cs typeface="Calibri" pitchFamily="34" charset="-120"/>
               </a:rPr>
-              <a:t>SUBSTANTIVE ACCURACY · 40%</a:t>
+              <a:t>SUBSTANTIVE ACCURACY </a:t>
             </a:r>
             <a:endParaRPr lang="en-US" sz="1400" dirty="0"/>
           </a:p>
@@ -12243,7 +12265,7 @@
                 <a:ea typeface="Calibri" pitchFamily="34" charset="-122"/>
                 <a:cs typeface="Calibri" pitchFamily="34" charset="-120"/>
               </a:rPr>
-              <a:t>TECHNICAL RESILIENCE · 30%</a:t>
+              <a:t>TECHNICAL RESILIENCE</a:t>
             </a:r>
             <a:endParaRPr lang="en-US" sz="1400" dirty="0"/>
           </a:p>
@@ -12410,7 +12432,7 @@
                 <a:ea typeface="Calibri" pitchFamily="34" charset="-122"/>
                 <a:cs typeface="Calibri" pitchFamily="34" charset="-120"/>
               </a:rPr>
-              <a:t>ARCHITECTURE · 30%</a:t>
+              <a:t>ARCHITECTURE</a:t>
             </a:r>
             <a:endParaRPr lang="en-US" sz="1400" dirty="0"/>
           </a:p>
@@ -16476,7 +16498,7 @@
                 <a:ea typeface="Calibri" pitchFamily="34" charset="-122"/>
                 <a:cs typeface="Calibri" pitchFamily="34" charset="-120"/>
               </a:rPr>
-              <a:t>Models — profile-swappable via models.yaml: cloud GPT nano/mini tiers (operator key) or local Ollama; BGE-M3 embeddings (MIT); local OCR</a:t>
+              <a:t>Models — profile-swappable via models.yaml: cloud GPT nano/mini tiers (operator key) or local Ollama; BGE-M3 embeddings (MIT); local OCR-VLM</a:t>
             </a:r>
             <a:endParaRPr lang="en-US" sz="1200" dirty="0"/>
           </a:p>

</xml_diff>